<commit_message>
Deck WCAG condensé régénéré pour le 9 octobre
</commit_message>
<xml_diff>
--- a/wcag/WCAG en langage clair - condensé.pptx
+++ b/wcag/WCAG en langage clair - condensé.pptx
@@ -1971,8 +1971,8 @@
         </p:blipFill>
         <p:spPr>
           <a:xfrm>
-            <a:off x="431369" y="260647"/>
-            <a:ext cx="4579487" cy="4149096"/>
+            <a:off x="475488" y="320040"/>
+            <a:ext cx="2560320" cy="2319695"/>
           </a:xfrm>
           <a:prstGeom prst="rect">
             <a:avLst/>
@@ -2001,8 +2001,8 @@
         </p:blipFill>
         <p:spPr>
           <a:xfrm>
-            <a:off x="8178299" y="776635"/>
-            <a:ext cx="3132658" cy="3132658"/>
+            <a:off x="9875520" y="777240"/>
+            <a:ext cx="1828800" cy="1828800"/>
           </a:xfrm>
           <a:prstGeom prst="rect">
             <a:avLst/>
@@ -5119,7 +5119,7 @@
                 </a:solidFill>
                 <a:latin typeface="Marianne"/>
               </a:rPr>
-              <a:t>juin 2026</a:t>
+              <a:t>9 octobre 2026</a:t>
             </a:r>
             <a:endParaRPr lang="fr-FR" cap="all" dirty="0"/>
           </a:p>
@@ -6013,7 +6013,7 @@
                 </a:solidFill>
                 <a:latin typeface="Marianne"/>
               </a:rPr>
-              <a:t>juin 2026</a:t>
+              <a:t>9 octobre 2026</a:t>
             </a:r>
             <a:endParaRPr lang="fr-FR" cap="all" dirty="0"/>
           </a:p>
@@ -6868,7 +6868,7 @@
                 </a:solidFill>
                 <a:latin typeface="Marianne"/>
               </a:rPr>
-              <a:t>juin 2026</a:t>
+              <a:t>9 octobre 2026</a:t>
             </a:r>
             <a:endParaRPr lang="fr-FR" cap="all" dirty="0"/>
           </a:p>
@@ -7601,7 +7601,7 @@
                 </a:solidFill>
                 <a:latin typeface="Marianne"/>
               </a:rPr>
-              <a:t>juin 2026</a:t>
+              <a:t>9 octobre 2026</a:t>
             </a:r>
             <a:endParaRPr lang="fr-FR" cap="all" dirty="0"/>
           </a:p>
@@ -8329,7 +8329,7 @@
                 </a:solidFill>
                 <a:latin typeface="Marianne"/>
               </a:rPr>
-              <a:t>juin 2026</a:t>
+              <a:t>9 octobre 2026</a:t>
             </a:r>
             <a:endParaRPr lang="fr-FR" cap="all" dirty="0"/>
           </a:p>
@@ -9140,7 +9140,7 @@
                 </a:solidFill>
                 <a:latin typeface="Marianne"/>
               </a:rPr>
-              <a:t>juin 2026</a:t>
+              <a:t>9 octobre 2026</a:t>
             </a:r>
             <a:endParaRPr lang="fr-FR" cap="all" dirty="0"/>
           </a:p>
@@ -10035,7 +10035,7 @@
                 </a:solidFill>
                 <a:latin typeface="Marianne"/>
               </a:rPr>
-              <a:t>juin 2026</a:t>
+              <a:t>9 octobre 2026</a:t>
             </a:r>
             <a:endParaRPr lang="fr-FR" cap="all" dirty="0"/>
           </a:p>
@@ -10890,7 +10890,7 @@
                 </a:solidFill>
                 <a:latin typeface="Marianne"/>
               </a:rPr>
-              <a:t>juin 2026</a:t>
+              <a:t>9 octobre 2026</a:t>
             </a:r>
             <a:endParaRPr lang="fr-FR" cap="all" dirty="0"/>
           </a:p>
@@ -11745,7 +11745,7 @@
                 </a:solidFill>
                 <a:latin typeface="Marianne"/>
               </a:rPr>
-              <a:t>juin 2026</a:t>
+              <a:t>9 octobre 2026</a:t>
             </a:r>
             <a:endParaRPr lang="fr-FR" cap="all" dirty="0"/>
           </a:p>
@@ -12600,7 +12600,7 @@
                 </a:solidFill>
                 <a:latin typeface="Marianne"/>
               </a:rPr>
-              <a:t>juin 2026</a:t>
+              <a:t>9 octobre 2026</a:t>
             </a:r>
             <a:endParaRPr lang="fr-FR" cap="all" dirty="0"/>
           </a:p>
@@ -13494,7 +13494,7 @@
                 </a:solidFill>
                 <a:latin typeface="Marianne"/>
               </a:rPr>
-              <a:t>juin 2026</a:t>
+              <a:t>9 octobre 2026</a:t>
             </a:r>
             <a:endParaRPr lang="fr-FR" cap="all" dirty="0"/>
           </a:p>
@@ -14350,7 +14350,7 @@
                 </a:solidFill>
                 <a:latin typeface="Marianne"/>
               </a:rPr>
-              <a:t>juin 2026</a:t>
+              <a:t>9 octobre 2026</a:t>
             </a:r>
             <a:endParaRPr lang="fr-FR" cap="all" dirty="0"/>
           </a:p>
@@ -14961,7 +14961,7 @@
                 </a:solidFill>
                 <a:latin typeface="Marianne"/>
               </a:rPr>
-              <a:t>juin 2026</a:t>
+              <a:t>9 octobre 2026</a:t>
             </a:r>
             <a:endParaRPr lang="fr-FR" cap="all" dirty="0"/>
           </a:p>

</xml_diff>

<commit_message>
Livrables : régénérer le paquet
</commit_message>
<xml_diff>
--- a/wcag/WCAG en langage clair - condensé.pptx
+++ b/wcag/WCAG en langage clair - condensé.pptx
@@ -4299,7 +4299,7 @@
                 <a:solidFill>
                   <a:srgbClr val="000091"/>
                 </a:solidFill>
-                <a:latin typeface="Marianne"/>
+                <a:latin typeface="Arial"/>
               </a:rPr>
               <a:t>Comment comprendre les principes WCAG</a:t>
             </a:r>
@@ -4332,7 +4332,7 @@
                 <a:solidFill>
                   <a:srgbClr val="666666"/>
                 </a:solidFill>
-                <a:latin typeface="Marianne"/>
+                <a:latin typeface="Arial"/>
               </a:rPr>
               <a:t>Principes WCAG et critères condensés</a:t>
             </a:r>
@@ -4364,7 +4364,7 @@
                 <a:solidFill>
                   <a:srgbClr val="666666"/>
                 </a:solidFill>
-                <a:latin typeface="Marianne"/>
+                <a:latin typeface="Arial"/>
               </a:rPr>
               <a:t>1</a:t>
             </a:r>
@@ -4422,7 +4422,7 @@
                 <a:solidFill>
                   <a:srgbClr val="FFFFFF"/>
                 </a:solidFill>
-                <a:latin typeface="Marianne"/>
+                <a:latin typeface="Arial"/>
               </a:rPr>
               <a:t>1</a:t>
             </a:r>
@@ -4461,7 +4461,7 @@
                 <a:solidFill>
                   <a:srgbClr val="161616"/>
                 </a:solidFill>
-                <a:latin typeface="Marianne"/>
+                <a:latin typeface="Arial"/>
               </a:rPr>
               <a:t>4 principes : percevoir, utiliser, comprendre, rester compatible</a:t>
             </a:r>
@@ -4518,7 +4518,7 @@
                 <a:solidFill>
                   <a:srgbClr val="FFFFFF"/>
                 </a:solidFill>
-                <a:latin typeface="Marianne"/>
+                <a:latin typeface="Arial"/>
               </a:rPr>
               <a:t>2</a:t>
             </a:r>
@@ -4557,7 +4557,7 @@
                 <a:solidFill>
                   <a:srgbClr val="161616"/>
                 </a:solidFill>
-                <a:latin typeface="Marianne"/>
+                <a:latin typeface="Arial"/>
               </a:rPr>
               <a:t>13 lignes directrices : les grands sujets à traiter</a:t>
             </a:r>
@@ -4614,7 +4614,7 @@
                 <a:solidFill>
                   <a:srgbClr val="FFFFFF"/>
                 </a:solidFill>
-                <a:latin typeface="Marianne"/>
+                <a:latin typeface="Arial"/>
               </a:rPr>
               <a:t>3</a:t>
             </a:r>
@@ -4653,7 +4653,7 @@
                 <a:solidFill>
                   <a:srgbClr val="161616"/>
                 </a:solidFill>
-                <a:latin typeface="Marianne"/>
+                <a:latin typeface="Arial"/>
               </a:rPr>
               <a:t>Critères de succès : les exigences testables</a:t>
             </a:r>
@@ -4710,7 +4710,7 @@
                 <a:solidFill>
                   <a:srgbClr val="FFFFFF"/>
                 </a:solidFill>
-                <a:latin typeface="Marianne"/>
+                <a:latin typeface="Arial"/>
               </a:rPr>
               <a:t>4</a:t>
             </a:r>
@@ -4749,7 +4749,7 @@
                 <a:solidFill>
                   <a:srgbClr val="161616"/>
                 </a:solidFill>
-                <a:latin typeface="Marianne"/>
+                <a:latin typeface="Arial"/>
               </a:rPr>
               <a:t>Preuves : test, mesure, exemple corrigé ou contenu modifié</a:t>
             </a:r>
@@ -4832,7 +4832,7 @@
                 <a:solidFill>
                   <a:srgbClr val="000091"/>
                 </a:solidFill>
-                <a:latin typeface="Marianne"/>
+                <a:latin typeface="Arial"/>
               </a:rPr>
               <a:t>Le bon réflexe</a:t>
             </a:r>
@@ -4871,7 +4871,7 @@
                 <a:solidFill>
                   <a:srgbClr val="161616"/>
                 </a:solidFill>
-                <a:latin typeface="Marianne"/>
+                <a:latin typeface="Arial"/>
               </a:rPr>
               <a:t>• </a:t>
             </a:r>
@@ -4880,7 +4880,7 @@
                 <a:solidFill>
                   <a:srgbClr val="161616"/>
                 </a:solidFill>
-                <a:latin typeface="Marianne"/>
+                <a:latin typeface="Arial"/>
               </a:rPr>
               <a:t>Ne pas apprendre la liste par cœur.</a:t>
             </a:r>
@@ -4896,7 +4896,7 @@
                 <a:solidFill>
                   <a:srgbClr val="161616"/>
                 </a:solidFill>
-                <a:latin typeface="Marianne"/>
+                <a:latin typeface="Arial"/>
               </a:rPr>
               <a:t>• </a:t>
             </a:r>
@@ -4905,7 +4905,7 @@
                 <a:solidFill>
                   <a:srgbClr val="161616"/>
                 </a:solidFill>
-                <a:latin typeface="Marianne"/>
+                <a:latin typeface="Arial"/>
               </a:rPr>
               <a:t>Savoir transformer un critère en question : que doit pouvoir faire la personne ?</a:t>
             </a:r>
@@ -4968,7 +4968,7 @@
                 <a:solidFill>
                   <a:srgbClr val="000091"/>
                 </a:solidFill>
-                <a:latin typeface="Marianne"/>
+                <a:latin typeface="Arial"/>
               </a:rPr>
               <a:t>WCAG 2.2 - Mise en FALC</a:t>
             </a:r>
@@ -5007,7 +5007,7 @@
                 <a:solidFill>
                   <a:srgbClr val="000091"/>
                 </a:solidFill>
-                <a:latin typeface="Marianne"/>
+                <a:latin typeface="Arial"/>
               </a:rPr>
               <a:t>Scannez-moi !</a:t>
             </a:r>
@@ -5046,7 +5046,7 @@
                 <a:solidFill>
                   <a:srgbClr val="000091"/>
                 </a:solidFill>
-                <a:latin typeface="Marianne"/>
+                <a:latin typeface="Arial"/>
               </a:rPr>
               <a:t>aaardvarkaccessibility.com/wcag-plain-english</a:t>
             </a:r>
@@ -5085,7 +5085,7 @@
                 <a:solidFill>
                   <a:srgbClr val="000091"/>
                 </a:solidFill>
-                <a:latin typeface="Marianne"/>
+                <a:latin typeface="Arial"/>
               </a:rPr>
               <a:t>WCAG 2.2 Card Deck - Johannes Lehner - CC BY-SA 4.0</a:t>
             </a:r>
@@ -5117,7 +5117,7 @@
                 <a:solidFill>
                   <a:srgbClr val="666666"/>
                 </a:solidFill>
-                <a:latin typeface="Marianne"/>
+                <a:latin typeface="Arial"/>
               </a:rPr>
               <a:t>9 octobre 2026</a:t>
             </a:r>
@@ -5155,7 +5155,7 @@
                 <a:solidFill>
                   <a:srgbClr val="666666"/>
                 </a:solidFill>
-                <a:latin typeface="Marianne"/>
+                <a:latin typeface="Arial"/>
               </a:rPr>
               <a:t>WCAG en langage clair / Carte mentale</a:t>
             </a:r>
@@ -5386,7 +5386,7 @@
                 <a:solidFill>
                   <a:srgbClr val="000091"/>
                 </a:solidFill>
-                <a:latin typeface="Marianne"/>
+                <a:latin typeface="Arial"/>
               </a:rPr>
               <a:t>Comprendre sans effort inutile - critères (1/3)</a:t>
             </a:r>
@@ -5419,7 +5419,7 @@
                 <a:solidFill>
                   <a:srgbClr val="666666"/>
                 </a:solidFill>
-                <a:latin typeface="Marianne"/>
+                <a:latin typeface="Arial"/>
               </a:rPr>
               <a:t>Principes WCAG et critères condensés</a:t>
             </a:r>
@@ -5451,7 +5451,7 @@
                 <a:solidFill>
                   <a:srgbClr val="666666"/>
                 </a:solidFill>
-                <a:latin typeface="Marianne"/>
+                <a:latin typeface="Arial"/>
               </a:rPr>
               <a:t>10</a:t>
             </a:r>
@@ -5491,7 +5491,7 @@
                 <a:solidFill>
                   <a:srgbClr val="000091"/>
                 </a:solidFill>
-                <a:latin typeface="Marianne"/>
+                <a:latin typeface="Arial"/>
               </a:rPr>
               <a:t>Les textes, parcours et formulaires doivent rester prévisibles, explicites et réparables en cas d’erreur.</a:t>
             </a:r>
@@ -5574,7 +5574,7 @@
                 <a:solidFill>
                   <a:srgbClr val="000091"/>
                 </a:solidFill>
-                <a:latin typeface="Marianne"/>
+                <a:latin typeface="Arial"/>
               </a:rPr>
               <a:t>Langue de la page</a:t>
             </a:r>
@@ -5613,7 +5613,7 @@
                 <a:solidFill>
                   <a:srgbClr val="161616"/>
                 </a:solidFill>
-                <a:latin typeface="Marianne"/>
+                <a:latin typeface="Arial"/>
               </a:rPr>
               <a:t>Chaque page doit comporter un attribut &lt;html lang=""&gt; correspondant à la langue principale de la page.</a:t>
             </a:r>
@@ -5696,7 +5696,7 @@
                 <a:solidFill>
                   <a:srgbClr val="000091"/>
                 </a:solidFill>
-                <a:latin typeface="Marianne"/>
+                <a:latin typeface="Arial"/>
               </a:rPr>
               <a:t>Langue d'un passage</a:t>
             </a:r>
@@ -5735,7 +5735,7 @@
                 <a:solidFill>
                   <a:srgbClr val="161616"/>
                 </a:solidFill>
-                <a:latin typeface="Marianne"/>
+                <a:latin typeface="Arial"/>
               </a:rPr>
               <a:t>Chaque passage d'un contenu rédigé dans une autre langue doit être notifié à l'aide de l'attribut lang approprié. Les expressions empruntées à une autre langue (comme "week-end", par exemple) n'ont pas besoin de cet attribut, sauf si la prononciation ou la compréhension est affectée.</a:t>
             </a:r>
@@ -5818,7 +5818,7 @@
                 <a:solidFill>
                   <a:srgbClr val="000091"/>
                 </a:solidFill>
-                <a:latin typeface="Marianne"/>
+                <a:latin typeface="Arial"/>
               </a:rPr>
               <a:t>Mots rares</a:t>
             </a:r>
@@ -5857,7 +5857,7 @@
                 <a:solidFill>
                   <a:srgbClr val="161616"/>
                 </a:solidFill>
-                <a:latin typeface="Marianne"/>
+                <a:latin typeface="Arial"/>
               </a:rPr>
               <a:t>Les termes utilisés de manière inhabituelle, le jargon et les expressions idiomatiques doivent être évités dans la mesure du possible, ou être expliqués dès leur première occurrence.</a:t>
             </a:r>
@@ -5940,7 +5940,7 @@
                 <a:solidFill>
                   <a:srgbClr val="000091"/>
                 </a:solidFill>
-                <a:latin typeface="Marianne"/>
+                <a:latin typeface="Arial"/>
               </a:rPr>
               <a:t>Prononciation</a:t>
             </a:r>
@@ -5979,7 +5979,7 @@
                 <a:solidFill>
                   <a:srgbClr val="161616"/>
                 </a:solidFill>
-                <a:latin typeface="Marianne"/>
+                <a:latin typeface="Arial"/>
               </a:rPr>
               <a:t>Lorsque la prononciation d'un mot peut varier et changer sa signification, il est nécessaire de clarifier le sens voulu pour éviter toute confusion ou ambiguïté.</a:t>
             </a:r>
@@ -6011,7 +6011,7 @@
                 <a:solidFill>
                   <a:srgbClr val="666666"/>
                 </a:solidFill>
-                <a:latin typeface="Marianne"/>
+                <a:latin typeface="Arial"/>
               </a:rPr>
               <a:t>9 octobre 2026</a:t>
             </a:r>
@@ -6049,7 +6049,7 @@
                 <a:solidFill>
                   <a:srgbClr val="666666"/>
                 </a:solidFill>
-                <a:latin typeface="Marianne"/>
+                <a:latin typeface="Arial"/>
               </a:rPr>
               <a:t>WCAG en langage clair / Comprendre sans effort inutile</a:t>
             </a:r>
@@ -6280,7 +6280,7 @@
                 <a:solidFill>
                   <a:srgbClr val="000091"/>
                 </a:solidFill>
-                <a:latin typeface="Marianne"/>
+                <a:latin typeface="Arial"/>
               </a:rPr>
               <a:t>Comprendre sans effort inutile - critères (2/3)</a:t>
             </a:r>
@@ -6313,7 +6313,7 @@
                 <a:solidFill>
                   <a:srgbClr val="666666"/>
                 </a:solidFill>
-                <a:latin typeface="Marianne"/>
+                <a:latin typeface="Arial"/>
               </a:rPr>
               <a:t>Principes WCAG et critères condensés</a:t>
             </a:r>
@@ -6345,7 +6345,7 @@
                 <a:solidFill>
                   <a:srgbClr val="666666"/>
                 </a:solidFill>
-                <a:latin typeface="Marianne"/>
+                <a:latin typeface="Arial"/>
               </a:rPr>
               <a:t>11</a:t>
             </a:r>
@@ -6429,7 +6429,7 @@
                 <a:solidFill>
                   <a:srgbClr val="000091"/>
                 </a:solidFill>
-                <a:latin typeface="Marianne"/>
+                <a:latin typeface="Arial"/>
               </a:rPr>
               <a:t>Au focus</a:t>
             </a:r>
@@ -6468,7 +6468,7 @@
                 <a:solidFill>
                   <a:srgbClr val="161616"/>
                 </a:solidFill>
-                <a:latin typeface="Marianne"/>
+                <a:latin typeface="Arial"/>
               </a:rPr>
               <a:t>Lorsqu'un élément reçoit le focus, aucun changement imprévu ne doit se produire (comme l'ouverture d'une fenêtre contextuelle, le déplacement du focus ou la validation d'un formulaire).</a:t>
             </a:r>
@@ -6551,7 +6551,7 @@
                 <a:solidFill>
                   <a:srgbClr val="000091"/>
                 </a:solidFill>
-                <a:latin typeface="Marianne"/>
+                <a:latin typeface="Arial"/>
               </a:rPr>
               <a:t>Abréviations</a:t>
             </a:r>
@@ -6590,7 +6590,7 @@
                 <a:solidFill>
                   <a:srgbClr val="161616"/>
                 </a:solidFill>
-                <a:latin typeface="Marianne"/>
+                <a:latin typeface="Arial"/>
               </a:rPr>
               <a:t>Les abréviations et acronymes doivent être évités dans la mesure du possible, ou être expliqués lors de leur première occurrence.</a:t>
             </a:r>
@@ -6673,7 +6673,7 @@
                 <a:solidFill>
                   <a:srgbClr val="000091"/>
                 </a:solidFill>
-                <a:latin typeface="Marianne"/>
+                <a:latin typeface="Arial"/>
               </a:rPr>
               <a:t>Lisibilité du texte</a:t>
             </a:r>
@@ -6712,7 +6712,7 @@
                 <a:solidFill>
                   <a:srgbClr val="161616"/>
                 </a:solidFill>
-                <a:latin typeface="Marianne"/>
+                <a:latin typeface="Arial"/>
               </a:rPr>
               <a:t>Si le contenu nécessite une capacité de lecture plus avancée que le premier cycle de l'enseignement secondaire (autrement dit la classe de 3e), il est essentiel de fournir une version simplifiée, un résumé, un support visuel ou une version audio pour faciliter la compréhension.</a:t>
             </a:r>
@@ -6795,7 +6795,7 @@
                 <a:solidFill>
                   <a:srgbClr val="000091"/>
                 </a:solidFill>
-                <a:latin typeface="Marianne"/>
+                <a:latin typeface="Arial"/>
               </a:rPr>
               <a:t>Prévention des erreurs (toutes)</a:t>
             </a:r>
@@ -6834,7 +6834,7 @@
                 <a:solidFill>
                   <a:srgbClr val="161616"/>
                 </a:solidFill>
-                <a:latin typeface="Marianne"/>
+                <a:latin typeface="Arial"/>
               </a:rPr>
               <a:t>Avant de valider l'envoi d'un formulaire, il doit être possible de vérifier les informations saisies et corriger les erreurs.</a:t>
             </a:r>
@@ -6866,7 +6866,7 @@
                 <a:solidFill>
                   <a:srgbClr val="666666"/>
                 </a:solidFill>
-                <a:latin typeface="Marianne"/>
+                <a:latin typeface="Arial"/>
               </a:rPr>
               <a:t>9 octobre 2026</a:t>
             </a:r>
@@ -6904,7 +6904,7 @@
                 <a:solidFill>
                   <a:srgbClr val="666666"/>
                 </a:solidFill>
-                <a:latin typeface="Marianne"/>
+                <a:latin typeface="Arial"/>
               </a:rPr>
               <a:t>WCAG en langage clair / Comprendre sans effort inutile</a:t>
             </a:r>
@@ -7135,7 +7135,7 @@
                 <a:solidFill>
                   <a:srgbClr val="000091"/>
                 </a:solidFill>
-                <a:latin typeface="Marianne"/>
+                <a:latin typeface="Arial"/>
               </a:rPr>
               <a:t>Comprendre sans effort inutile - critères (3/3)</a:t>
             </a:r>
@@ -7168,7 +7168,7 @@
                 <a:solidFill>
                   <a:srgbClr val="666666"/>
                 </a:solidFill>
-                <a:latin typeface="Marianne"/>
+                <a:latin typeface="Arial"/>
               </a:rPr>
               <a:t>Principes WCAG et critères condensés</a:t>
             </a:r>
@@ -7200,7 +7200,7 @@
                 <a:solidFill>
                   <a:srgbClr val="666666"/>
                 </a:solidFill>
-                <a:latin typeface="Marianne"/>
+                <a:latin typeface="Arial"/>
               </a:rPr>
               <a:t>12</a:t>
             </a:r>
@@ -7284,7 +7284,7 @@
                 <a:solidFill>
                   <a:srgbClr val="000091"/>
                 </a:solidFill>
-                <a:latin typeface="Marianne"/>
+                <a:latin typeface="Arial"/>
               </a:rPr>
               <a:t>Saisie redondante</a:t>
             </a:r>
@@ -7323,7 +7323,7 @@
                 <a:solidFill>
                   <a:srgbClr val="161616"/>
                 </a:solidFill>
-                <a:latin typeface="Marianne"/>
+                <a:latin typeface="Arial"/>
               </a:rPr>
               <a:t>Ne demandez pas les mêmes informations deux fois au cours d'un même processus. Proposez des champs préremplis ou des options de sélection si les informations ont déjà été fournies au préalable.</a:t>
             </a:r>
@@ -7406,7 +7406,7 @@
                 <a:solidFill>
                   <a:srgbClr val="000091"/>
                 </a:solidFill>
-                <a:latin typeface="Marianne"/>
+                <a:latin typeface="Arial"/>
               </a:rPr>
               <a:t>Authentification accessible (minimum)</a:t>
             </a:r>
@@ -7445,7 +7445,7 @@
                 <a:solidFill>
                   <a:srgbClr val="161616"/>
                 </a:solidFill>
-                <a:latin typeface="Marianne"/>
+                <a:latin typeface="Arial"/>
               </a:rPr>
               <a:t>L'authentification ne doit pas reposer uniquement sur la mémoire. Elle doit autoriser le copier-coller, les gestionnaires de mots de passe ou d'autres options (comme la vérification par e-mail).</a:t>
             </a:r>
@@ -7528,7 +7528,7 @@
                 <a:solidFill>
                   <a:srgbClr val="000091"/>
                 </a:solidFill>
-                <a:latin typeface="Marianne"/>
+                <a:latin typeface="Arial"/>
               </a:rPr>
               <a:t>Authentification accessible (améliorée)</a:t>
             </a:r>
@@ -7567,7 +7567,7 @@
                 <a:solidFill>
                   <a:srgbClr val="161616"/>
                 </a:solidFill>
-                <a:latin typeface="Marianne"/>
+                <a:latin typeface="Arial"/>
               </a:rPr>
               <a:t>L'authentification ne doit pas reposer sur la mémoire ou la reconnaissance (comme résoudre des énigmes, se souvenir d'images ou utiliser des CAPTCHA).</a:t>
             </a:r>
@@ -7599,7 +7599,7 @@
                 <a:solidFill>
                   <a:srgbClr val="666666"/>
                 </a:solidFill>
-                <a:latin typeface="Marianne"/>
+                <a:latin typeface="Arial"/>
               </a:rPr>
               <a:t>9 octobre 2026</a:t>
             </a:r>
@@ -7637,7 +7637,7 @@
                 <a:solidFill>
                   <a:srgbClr val="666666"/>
                 </a:solidFill>
-                <a:latin typeface="Marianne"/>
+                <a:latin typeface="Arial"/>
               </a:rPr>
               <a:t>WCAG en langage clair / Comprendre sans effort inutile</a:t>
             </a:r>
@@ -7824,7 +7824,7 @@
                 <a:solidFill>
                   <a:srgbClr val="000091"/>
                 </a:solidFill>
-                <a:latin typeface="Marianne"/>
+                <a:latin typeface="Arial"/>
               </a:rPr>
               <a:t>Rester compatible - critères</a:t>
             </a:r>
@@ -7857,7 +7857,7 @@
                 <a:solidFill>
                   <a:srgbClr val="666666"/>
                 </a:solidFill>
-                <a:latin typeface="Marianne"/>
+                <a:latin typeface="Arial"/>
               </a:rPr>
               <a:t>Principes WCAG et critères condensés</a:t>
             </a:r>
@@ -7889,7 +7889,7 @@
                 <a:solidFill>
                   <a:srgbClr val="666666"/>
                 </a:solidFill>
-                <a:latin typeface="Marianne"/>
+                <a:latin typeface="Arial"/>
               </a:rPr>
               <a:t>13</a:t>
             </a:r>
@@ -7929,7 +7929,7 @@
                 <a:solidFill>
                   <a:srgbClr val="000091"/>
                 </a:solidFill>
-                <a:latin typeface="Marianne"/>
+                <a:latin typeface="Arial"/>
               </a:rPr>
               <a:t>L’interface doit pouvoir être comprise par les aides techniques, les navigateurs et les outils de lecture.</a:t>
             </a:r>
@@ -8012,7 +8012,7 @@
                 <a:solidFill>
                   <a:srgbClr val="000091"/>
                 </a:solidFill>
-                <a:latin typeface="Marianne"/>
+                <a:latin typeface="Arial"/>
               </a:rPr>
               <a:t>Analyse syntaxique (obsolète et supprimé)</a:t>
             </a:r>
@@ -8051,7 +8051,7 @@
                 <a:solidFill>
                   <a:srgbClr val="161616"/>
                 </a:solidFill>
-                <a:latin typeface="Marianne"/>
+                <a:latin typeface="Arial"/>
               </a:rPr>
               <a:t>Ce critère nécessitait un code HTML correctement structuré et sans erreurs critiques (telles que des balises manquantes ou des identifiants en double). Bien que cette exigence ait été supprimée, elle reste utile en termes de compatibilité.</a:t>
             </a:r>
@@ -8134,7 +8134,7 @@
                 <a:solidFill>
                   <a:srgbClr val="000091"/>
                 </a:solidFill>
-                <a:latin typeface="Marianne"/>
+                <a:latin typeface="Arial"/>
               </a:rPr>
               <a:t>Nom, rôle et valeur</a:t>
             </a:r>
@@ -8173,7 +8173,7 @@
                 <a:solidFill>
                   <a:srgbClr val="161616"/>
                 </a:solidFill>
-                <a:latin typeface="Marianne"/>
+                <a:latin typeface="Arial"/>
               </a:rPr>
               <a:t>Les éléments interactifs doivent disposer d'un nom clair (ce qu'ils sont), d'un rôle approprié (ce qu'ils font), et de toute valeur ou état actuel, afin que les technologies d'assistance puissent les interpréter et interagir correctement avec eux.</a:t>
             </a:r>
@@ -8256,7 +8256,7 @@
                 <a:solidFill>
                   <a:srgbClr val="000091"/>
                 </a:solidFill>
-                <a:latin typeface="Marianne"/>
+                <a:latin typeface="Arial"/>
               </a:rPr>
               <a:t>Messages d'état</a:t>
             </a:r>
@@ -8295,7 +8295,7 @@
                 <a:solidFill>
                   <a:srgbClr val="161616"/>
                 </a:solidFill>
-                <a:latin typeface="Marianne"/>
+                <a:latin typeface="Arial"/>
               </a:rPr>
               <a:t>Les mises à jour d'état (telles que "formulaire envoyé" ou "5 articles dans le panier") doivent être codées avec des rôles appropriés (tels que role="status" ou role="alert"), être détectables par les technologies d'assistance, et ne pas nécessiter de déplacement du focus.</a:t>
             </a:r>
@@ -8327,7 +8327,7 @@
                 <a:solidFill>
                   <a:srgbClr val="666666"/>
                 </a:solidFill>
-                <a:latin typeface="Marianne"/>
+                <a:latin typeface="Arial"/>
               </a:rPr>
               <a:t>9 octobre 2026</a:t>
             </a:r>
@@ -8365,7 +8365,7 @@
                 <a:solidFill>
                   <a:srgbClr val="666666"/>
                 </a:solidFill>
-                <a:latin typeface="Marianne"/>
+                <a:latin typeface="Arial"/>
               </a:rPr>
               <a:t>WCAG en langage clair / Rester compatible</a:t>
             </a:r>
@@ -8552,7 +8552,7 @@
                 <a:solidFill>
                   <a:srgbClr val="000091"/>
                 </a:solidFill>
-                <a:latin typeface="Marianne"/>
+                <a:latin typeface="Arial"/>
               </a:rPr>
               <a:t>Les 4 grandes questions</a:t>
             </a:r>
@@ -8585,7 +8585,7 @@
                 <a:solidFill>
                   <a:srgbClr val="666666"/>
                 </a:solidFill>
-                <a:latin typeface="Marianne"/>
+                <a:latin typeface="Arial"/>
               </a:rPr>
               <a:t>Principes WCAG et critères condensés</a:t>
             </a:r>
@@ -8617,7 +8617,7 @@
                 <a:solidFill>
                   <a:srgbClr val="666666"/>
                 </a:solidFill>
-                <a:latin typeface="Marianne"/>
+                <a:latin typeface="Arial"/>
               </a:rPr>
               <a:t>2</a:t>
             </a:r>
@@ -8701,7 +8701,7 @@
                 <a:solidFill>
                   <a:srgbClr val="000091"/>
                 </a:solidFill>
-                <a:latin typeface="Marianne"/>
+                <a:latin typeface="Arial"/>
               </a:rPr>
               <a:t>Percevoir</a:t>
             </a:r>
@@ -8740,7 +8740,7 @@
                 <a:solidFill>
                   <a:srgbClr val="161616"/>
                 </a:solidFill>
-                <a:latin typeface="Marianne"/>
+                <a:latin typeface="Arial"/>
               </a:rPr>
               <a:t>L’information reste disponible si je ne vois pas ou n’entends pas comme prévu.</a:t>
             </a:r>
@@ -8823,7 +8823,7 @@
                 <a:solidFill>
                   <a:srgbClr val="000091"/>
                 </a:solidFill>
-                <a:latin typeface="Marianne"/>
+                <a:latin typeface="Arial"/>
               </a:rPr>
               <a:t>Utiliser</a:t>
             </a:r>
@@ -8862,7 +8862,7 @@
                 <a:solidFill>
                   <a:srgbClr val="161616"/>
                 </a:solidFill>
-                <a:latin typeface="Marianne"/>
+                <a:latin typeface="Arial"/>
               </a:rPr>
               <a:t>Je peux naviguer, agir et terminer sans piège ni geste imposé.</a:t>
             </a:r>
@@ -8945,7 +8945,7 @@
                 <a:solidFill>
                   <a:srgbClr val="000091"/>
                 </a:solidFill>
-                <a:latin typeface="Marianne"/>
+                <a:latin typeface="Arial"/>
               </a:rPr>
               <a:t>Comprendre</a:t>
             </a:r>
@@ -8984,7 +8984,7 @@
                 <a:solidFill>
                   <a:srgbClr val="161616"/>
                 </a:solidFill>
-                <a:latin typeface="Marianne"/>
+                <a:latin typeface="Arial"/>
               </a:rPr>
               <a:t>Les mots, formulaires et comportements restent prévisibles.</a:t>
             </a:r>
@@ -9067,7 +9067,7 @@
                 <a:solidFill>
                   <a:srgbClr val="000091"/>
                 </a:solidFill>
-                <a:latin typeface="Marianne"/>
+                <a:latin typeface="Arial"/>
               </a:rPr>
               <a:t>Compatible</a:t>
             </a:r>
@@ -9106,7 +9106,7 @@
                 <a:solidFill>
                   <a:srgbClr val="161616"/>
                 </a:solidFill>
-                <a:latin typeface="Marianne"/>
+                <a:latin typeface="Arial"/>
               </a:rPr>
               <a:t>Les aides techniques peuvent comprendre l’interface aujourd’hui et demain.</a:t>
             </a:r>
@@ -9138,7 +9138,7 @@
                 <a:solidFill>
                   <a:srgbClr val="666666"/>
                 </a:solidFill>
-                <a:latin typeface="Marianne"/>
+                <a:latin typeface="Arial"/>
               </a:rPr>
               <a:t>9 octobre 2026</a:t>
             </a:r>
@@ -9176,7 +9176,7 @@
                 <a:solidFill>
                   <a:srgbClr val="666666"/>
                 </a:solidFill>
-                <a:latin typeface="Marianne"/>
+                <a:latin typeface="Arial"/>
               </a:rPr>
               <a:t>WCAG en langage clair / Questions</a:t>
             </a:r>
@@ -9407,7 +9407,7 @@
                 <a:solidFill>
                   <a:srgbClr val="000091"/>
                 </a:solidFill>
-                <a:latin typeface="Marianne"/>
+                <a:latin typeface="Arial"/>
               </a:rPr>
               <a:t>Percevoir l'information - critères (1/4)</a:t>
             </a:r>
@@ -9440,7 +9440,7 @@
                 <a:solidFill>
                   <a:srgbClr val="666666"/>
                 </a:solidFill>
-                <a:latin typeface="Marianne"/>
+                <a:latin typeface="Arial"/>
               </a:rPr>
               <a:t>Principes WCAG et critères condensés</a:t>
             </a:r>
@@ -9472,7 +9472,7 @@
                 <a:solidFill>
                   <a:srgbClr val="666666"/>
                 </a:solidFill>
-                <a:latin typeface="Marianne"/>
+                <a:latin typeface="Arial"/>
               </a:rPr>
               <a:t>3</a:t>
             </a:r>
@@ -9512,7 +9512,7 @@
                 <a:solidFill>
                   <a:srgbClr val="000091"/>
                 </a:solidFill>
-                <a:latin typeface="Marianne"/>
+                <a:latin typeface="Arial"/>
               </a:rPr>
               <a:t>Les contenus doivent rester disponibles sous plusieurs formes : texte, audio, image, structure, contraste.</a:t>
             </a:r>
@@ -9595,7 +9595,7 @@
                 <a:solidFill>
                   <a:srgbClr val="000091"/>
                 </a:solidFill>
-                <a:latin typeface="Marianne"/>
+                <a:latin typeface="Arial"/>
               </a:rPr>
               <a:t>Contenu non textuel</a:t>
             </a:r>
@@ -9634,7 +9634,7 @@
                 <a:solidFill>
                   <a:srgbClr val="161616"/>
                 </a:solidFill>
-                <a:latin typeface="Marianne"/>
+                <a:latin typeface="Arial"/>
               </a:rPr>
               <a:t>Toutes les images et contenus non textuels (icônes, graphiques, sons, CAPTCHA, commandes) doivent être accompagnés d'une alternative textuelle décrivant leur signification. Le contenu purement esthétique peut être masqué pour les technologies d'assistance (par exemple, en utilisant un attribut alt vide).</a:t>
             </a:r>
@@ -9717,7 +9717,7 @@
                 <a:solidFill>
                   <a:srgbClr val="000091"/>
                 </a:solidFill>
-                <a:latin typeface="Marianne"/>
+                <a:latin typeface="Arial"/>
               </a:rPr>
               <a:t>Contenus seulement audio et seulement vidéo (pré-enregistré)</a:t>
             </a:r>
@@ -9756,7 +9756,7 @@
                 <a:solidFill>
                   <a:srgbClr val="161616"/>
                 </a:solidFill>
-                <a:latin typeface="Marianne"/>
+                <a:latin typeface="Arial"/>
               </a:rPr>
               <a:t>Les contenus seulement audio pré-enregistrés doivent disposer d'une transcription.
 Les contenus seulement vidéo pré-enregistrés doivent disposer d'une description textuelle ou d'une audiodescription.</a:t>
@@ -9840,7 +9840,7 @@
                 <a:solidFill>
                   <a:srgbClr val="000091"/>
                 </a:solidFill>
-                <a:latin typeface="Marianne"/>
+                <a:latin typeface="Arial"/>
               </a:rPr>
               <a:t>Sous-titres (pré-enregistré)</a:t>
             </a:r>
@@ -9879,7 +9879,7 @@
                 <a:solidFill>
                   <a:srgbClr val="161616"/>
                 </a:solidFill>
-                <a:latin typeface="Marianne"/>
+                <a:latin typeface="Arial"/>
               </a:rPr>
               <a:t>Les contenus vidéo pré-enregistrés contenant de l'audio doivent disposer de sous-titres synchronisés comprenant l'intégralité des paroles, et les sons pertinents (la musique, les alarmes ou les rires, entre autres).</a:t>
             </a:r>
@@ -9962,7 +9962,7 @@
                 <a:solidFill>
                   <a:srgbClr val="000091"/>
                 </a:solidFill>
-                <a:latin typeface="Marianne"/>
+                <a:latin typeface="Arial"/>
               </a:rPr>
               <a:t>Audio-description ou version de remplacement (pré-enregistré)</a:t>
             </a:r>
@@ -10001,7 +10001,7 @@
                 <a:solidFill>
                   <a:srgbClr val="161616"/>
                 </a:solidFill>
-                <a:latin typeface="Marianne"/>
+                <a:latin typeface="Arial"/>
               </a:rPr>
               <a:t>Les éléments visuels importants apparaissant dans des contenus vidéo pré-enregistrés doivent être décrits via une audiodescription, ou une alternative textuelle.</a:t>
             </a:r>
@@ -10033,7 +10033,7 @@
                 <a:solidFill>
                   <a:srgbClr val="666666"/>
                 </a:solidFill>
-                <a:latin typeface="Marianne"/>
+                <a:latin typeface="Arial"/>
               </a:rPr>
               <a:t>9 octobre 2026</a:t>
             </a:r>
@@ -10071,7 +10071,7 @@
                 <a:solidFill>
                   <a:srgbClr val="666666"/>
                 </a:solidFill>
-                <a:latin typeface="Marianne"/>
+                <a:latin typeface="Arial"/>
               </a:rPr>
               <a:t>WCAG en langage clair / Percevoir l'information</a:t>
             </a:r>
@@ -10302,7 +10302,7 @@
                 <a:solidFill>
                   <a:srgbClr val="000091"/>
                 </a:solidFill>
-                <a:latin typeface="Marianne"/>
+                <a:latin typeface="Arial"/>
               </a:rPr>
               <a:t>Percevoir l'information - critères (2/4)</a:t>
             </a:r>
@@ -10335,7 +10335,7 @@
                 <a:solidFill>
                   <a:srgbClr val="666666"/>
                 </a:solidFill>
-                <a:latin typeface="Marianne"/>
+                <a:latin typeface="Arial"/>
               </a:rPr>
               <a:t>Principes WCAG et critères condensés</a:t>
             </a:r>
@@ -10367,7 +10367,7 @@
                 <a:solidFill>
                   <a:srgbClr val="666666"/>
                 </a:solidFill>
-                <a:latin typeface="Marianne"/>
+                <a:latin typeface="Arial"/>
               </a:rPr>
               <a:t>4</a:t>
             </a:r>
@@ -10451,7 +10451,7 @@
                 <a:solidFill>
                   <a:srgbClr val="000091"/>
                 </a:solidFill>
-                <a:latin typeface="Marianne"/>
+                <a:latin typeface="Arial"/>
               </a:rPr>
               <a:t>Sous-titres (en direct)</a:t>
             </a:r>
@@ -10490,7 +10490,7 @@
                 <a:solidFill>
                   <a:srgbClr val="161616"/>
                 </a:solidFill>
-                <a:latin typeface="Marianne"/>
+                <a:latin typeface="Arial"/>
               </a:rPr>
               <a:t>Les contenus vidéo diffusés en direct contenant de l'audio doivent disposer d'un sous-titrage en temps réel reprenant les paroles, et les sons importants (la musique, les alarmes ou les rires, entre autres).</a:t>
             </a:r>
@@ -10573,7 +10573,7 @@
                 <a:solidFill>
                   <a:srgbClr val="000091"/>
                 </a:solidFill>
-                <a:latin typeface="Marianne"/>
+                <a:latin typeface="Arial"/>
               </a:rPr>
               <a:t>Audio-description (pré-enregistré)</a:t>
             </a:r>
@@ -10612,7 +10612,7 @@
                 <a:solidFill>
                   <a:srgbClr val="161616"/>
                 </a:solidFill>
-                <a:latin typeface="Marianne"/>
+                <a:latin typeface="Arial"/>
               </a:rPr>
               <a:t>Les éléments visuels importants apparaissant dans des contenus vidéo pré-enregistrés contenant de l'audio doivent être décrits via une audio-description, sauf s'ils sont déjà explicités dans la bande sonore principale.</a:t>
             </a:r>
@@ -10695,7 +10695,7 @@
                 <a:solidFill>
                   <a:srgbClr val="000091"/>
                 </a:solidFill>
-                <a:latin typeface="Marianne"/>
+                <a:latin typeface="Arial"/>
               </a:rPr>
               <a:t>Langue des signes (pré-enregistré)</a:t>
             </a:r>
@@ -10734,7 +10734,7 @@
                 <a:solidFill>
                   <a:srgbClr val="161616"/>
                 </a:solidFill>
-                <a:latin typeface="Marianne"/>
+                <a:latin typeface="Arial"/>
               </a:rPr>
               <a:t>Tous les contenus vidéo pré-enregistrés contenant de l'audio doivent disposer d'une interprétation en langue des signes.</a:t>
             </a:r>
@@ -10817,7 +10817,7 @@
                 <a:solidFill>
                   <a:srgbClr val="000091"/>
                 </a:solidFill>
-                <a:latin typeface="Marianne"/>
+                <a:latin typeface="Arial"/>
               </a:rPr>
               <a:t>Audio-description étendue (pré-enregistré)</a:t>
             </a:r>
@@ -10856,7 +10856,7 @@
                 <a:solidFill>
                   <a:srgbClr val="161616"/>
                 </a:solidFill>
-                <a:latin typeface="Marianne"/>
+                <a:latin typeface="Arial"/>
               </a:rPr>
               <a:t>Les contenus vidéo pré-enregistrés doivent disposer d'une audio-description étendue s'ils possèdent des éléments visuels importants tels que des détails visuels essentiels, du texte apparaissant à l'écran sans être prononcé à voix haute, ou des scènes dépourvues de pauses sonores et qui ne peuvent donc pas être décrites durant la lecture.</a:t>
             </a:r>
@@ -10888,7 +10888,7 @@
                 <a:solidFill>
                   <a:srgbClr val="666666"/>
                 </a:solidFill>
-                <a:latin typeface="Marianne"/>
+                <a:latin typeface="Arial"/>
               </a:rPr>
               <a:t>9 octobre 2026</a:t>
             </a:r>
@@ -10926,7 +10926,7 @@
                 <a:solidFill>
                   <a:srgbClr val="666666"/>
                 </a:solidFill>
-                <a:latin typeface="Marianne"/>
+                <a:latin typeface="Arial"/>
               </a:rPr>
               <a:t>WCAG en langage clair / Percevoir l'information</a:t>
             </a:r>
@@ -11157,7 +11157,7 @@
                 <a:solidFill>
                   <a:srgbClr val="000091"/>
                 </a:solidFill>
-                <a:latin typeface="Marianne"/>
+                <a:latin typeface="Arial"/>
               </a:rPr>
               <a:t>Percevoir l'information - critères (3/4)</a:t>
             </a:r>
@@ -11190,7 +11190,7 @@
                 <a:solidFill>
                   <a:srgbClr val="666666"/>
                 </a:solidFill>
-                <a:latin typeface="Marianne"/>
+                <a:latin typeface="Arial"/>
               </a:rPr>
               <a:t>Principes WCAG et critères condensés</a:t>
             </a:r>
@@ -11222,7 +11222,7 @@
                 <a:solidFill>
                   <a:srgbClr val="666666"/>
                 </a:solidFill>
-                <a:latin typeface="Marianne"/>
+                <a:latin typeface="Arial"/>
               </a:rPr>
               <a:t>5</a:t>
             </a:r>
@@ -11306,7 +11306,7 @@
                 <a:solidFill>
                   <a:srgbClr val="000091"/>
                 </a:solidFill>
-                <a:latin typeface="Marianne"/>
+                <a:latin typeface="Arial"/>
               </a:rPr>
               <a:t>Texte sous forme d'image</a:t>
             </a:r>
@@ -11345,7 +11345,7 @@
                 <a:solidFill>
                   <a:srgbClr val="161616"/>
                 </a:solidFill>
-                <a:latin typeface="Marianne"/>
+                <a:latin typeface="Arial"/>
               </a:rPr>
               <a:t>Le contenu textuel doit être codé comme du texte, et non comme des images, sauf si une représentation visuelle spécifique est indispensable (par exemple, un logo).</a:t>
             </a:r>
@@ -11428,7 +11428,7 @@
                 <a:solidFill>
                   <a:srgbClr val="000091"/>
                 </a:solidFill>
-                <a:latin typeface="Marianne"/>
+                <a:latin typeface="Arial"/>
               </a:rPr>
               <a:t>Contraste (amélioré)</a:t>
             </a:r>
@@ -11467,7 +11467,7 @@
                 <a:solidFill>
                   <a:srgbClr val="161616"/>
                 </a:solidFill>
-                <a:latin typeface="Marianne"/>
+                <a:latin typeface="Arial"/>
               </a:rPr>
               <a:t>Le contraste du texte par rapport à son arrière-plan doit être d'au moins 7:1 pour un texte classique, ou 4,5:1 pour un texte de grande taille (supérieur à 24px, ou en gras et supérieur à 19px).</a:t>
             </a:r>
@@ -11550,7 +11550,7 @@
                 <a:solidFill>
                   <a:srgbClr val="000091"/>
                 </a:solidFill>
-                <a:latin typeface="Marianne"/>
+                <a:latin typeface="Arial"/>
               </a:rPr>
               <a:t>Texte sous forme d'image (sans exception)</a:t>
             </a:r>
@@ -11589,7 +11589,7 @@
                 <a:solidFill>
                   <a:srgbClr val="161616"/>
                 </a:solidFill>
-                <a:latin typeface="Marianne"/>
+                <a:latin typeface="Arial"/>
               </a:rPr>
               <a:t>Le contenu textuel doit toujours être codé comme du texte, et non comme des images (sans exception, même pour des raisons esthétiques).</a:t>
             </a:r>
@@ -11672,7 +11672,7 @@
                 <a:solidFill>
                   <a:srgbClr val="000091"/>
                 </a:solidFill>
-                <a:latin typeface="Marianne"/>
+                <a:latin typeface="Arial"/>
               </a:rPr>
               <a:t>Redistribution</a:t>
             </a:r>
@@ -11711,7 +11711,7 @@
                 <a:solidFill>
                   <a:srgbClr val="161616"/>
                 </a:solidFill>
-                <a:latin typeface="Marianne"/>
+                <a:latin typeface="Arial"/>
               </a:rPr>
               <a:t>Le contenu doit rester fonctionnel et lisible lorsqu'il est zoomé à 400 %, ou affiché sur une largeur de 320 px, sans recourir à aucun défilement, qu'il soit vertical ou horizontal (sauf pour les tableaux, les cartes et les contenus similaires).</a:t>
             </a:r>
@@ -11743,7 +11743,7 @@
                 <a:solidFill>
                   <a:srgbClr val="666666"/>
                 </a:solidFill>
-                <a:latin typeface="Marianne"/>
+                <a:latin typeface="Arial"/>
               </a:rPr>
               <a:t>9 octobre 2026</a:t>
             </a:r>
@@ -11781,7 +11781,7 @@
                 <a:solidFill>
                   <a:srgbClr val="666666"/>
                 </a:solidFill>
-                <a:latin typeface="Marianne"/>
+                <a:latin typeface="Arial"/>
               </a:rPr>
               <a:t>WCAG en langage clair / Percevoir l'information</a:t>
             </a:r>
@@ -12012,7 +12012,7 @@
                 <a:solidFill>
                   <a:srgbClr val="000091"/>
                 </a:solidFill>
-                <a:latin typeface="Marianne"/>
+                <a:latin typeface="Arial"/>
               </a:rPr>
               <a:t>Percevoir l'information - critères (4/4)</a:t>
             </a:r>
@@ -12045,7 +12045,7 @@
                 <a:solidFill>
                   <a:srgbClr val="666666"/>
                 </a:solidFill>
-                <a:latin typeface="Marianne"/>
+                <a:latin typeface="Arial"/>
               </a:rPr>
               <a:t>Principes WCAG et critères condensés</a:t>
             </a:r>
@@ -12077,7 +12077,7 @@
                 <a:solidFill>
                   <a:srgbClr val="666666"/>
                 </a:solidFill>
-                <a:latin typeface="Marianne"/>
+                <a:latin typeface="Arial"/>
               </a:rPr>
               <a:t>6</a:t>
             </a:r>
@@ -12161,7 +12161,7 @@
                 <a:solidFill>
                   <a:srgbClr val="000091"/>
                 </a:solidFill>
-                <a:latin typeface="Marianne"/>
+                <a:latin typeface="Arial"/>
               </a:rPr>
               <a:t>Arrière-plan sonore de faible volume ou absent</a:t>
             </a:r>
@@ -12200,7 +12200,7 @@
                 <a:solidFill>
                   <a:srgbClr val="161616"/>
                 </a:solidFill>
-                <a:latin typeface="Marianne"/>
+                <a:latin typeface="Arial"/>
               </a:rPr>
               <a:t>Pour les contenus audio pré-enregistrés contenant des paroles, tout bruit de fond doit être au minimum 20 dB plus faible que les dialogues, ou pouvoir être désactivé.</a:t>
             </a:r>
@@ -12283,7 +12283,7 @@
                 <a:solidFill>
                   <a:srgbClr val="000091"/>
                 </a:solidFill>
-                <a:latin typeface="Marianne"/>
+                <a:latin typeface="Arial"/>
               </a:rPr>
               <a:t>Présentation visuelle</a:t>
             </a:r>
@@ -12322,7 +12322,7 @@
                 <a:solidFill>
                   <a:srgbClr val="161616"/>
                 </a:solidFill>
-                <a:latin typeface="Marianne"/>
+                <a:latin typeface="Arial"/>
               </a:rPr>
               <a:t>Les blocs de textes (tels que les paragraphes) doivent avoir une hauteur de ligne d'au moins 1.5, ne pas être justifiés, rester limités à 80 caractères par ligne (ou 40 pour des scripts CJK), et permettre aux utilisateurs d'ajuster l'espacement et les couleurs du texte à l'aide de styles personnalisés.</a:t>
             </a:r>
@@ -12405,7 +12405,7 @@
                 <a:solidFill>
                   <a:srgbClr val="000091"/>
                 </a:solidFill>
-                <a:latin typeface="Marianne"/>
+                <a:latin typeface="Arial"/>
               </a:rPr>
               <a:t>Contraste du contenu non textuel</a:t>
             </a:r>
@@ -12444,7 +12444,7 @@
                 <a:solidFill>
                   <a:srgbClr val="161616"/>
                 </a:solidFill>
-                <a:latin typeface="Marianne"/>
+                <a:latin typeface="Arial"/>
               </a:rPr>
               <a:t>Les éléments interactifs (boutons, champs de saisie, indicateurs de focus, par exemple) et graphiques porteurs de sens (icônes, tableaux, courbes graphiques, par exemple) doivent présenter un rapport de contraste d'au moins 3:1 avec les couleurs adjacentes.</a:t>
             </a:r>
@@ -12527,7 +12527,7 @@
                 <a:solidFill>
                   <a:srgbClr val="000091"/>
                 </a:solidFill>
-                <a:latin typeface="Marianne"/>
+                <a:latin typeface="Arial"/>
               </a:rPr>
               <a:t>Espacement du texte</a:t>
             </a:r>
@@ -12566,7 +12566,7 @@
                 <a:solidFill>
                   <a:srgbClr val="161616"/>
                 </a:solidFill>
-                <a:latin typeface="Marianne"/>
+                <a:latin typeface="Arial"/>
               </a:rPr>
               <a:t>Le texte doit rester lisible et fonctionnel lorsque l'espacement est modifié à l'aide de styles personnalisés, pour au moins 1,5x la hauteur de ligne, 2x l'espacement entre les paragraphes, 0,12x l'espacement des lettres, 0,16x l'espacement entre les mots, sans que le contenu ne soit caché ou coupé.</a:t>
             </a:r>
@@ -12598,7 +12598,7 @@
                 <a:solidFill>
                   <a:srgbClr val="666666"/>
                 </a:solidFill>
-                <a:latin typeface="Marianne"/>
+                <a:latin typeface="Arial"/>
               </a:rPr>
               <a:t>9 octobre 2026</a:t>
             </a:r>
@@ -12636,7 +12636,7 @@
                 <a:solidFill>
                   <a:srgbClr val="666666"/>
                 </a:solidFill>
-                <a:latin typeface="Marianne"/>
+                <a:latin typeface="Arial"/>
               </a:rPr>
               <a:t>WCAG en langage clair / Percevoir l'information</a:t>
             </a:r>
@@ -12867,7 +12867,7 @@
                 <a:solidFill>
                   <a:srgbClr val="000091"/>
                 </a:solidFill>
-                <a:latin typeface="Marianne"/>
+                <a:latin typeface="Arial"/>
               </a:rPr>
               <a:t>Utiliser sans obstacle - critères (1/3)</a:t>
             </a:r>
@@ -12900,7 +12900,7 @@
                 <a:solidFill>
                   <a:srgbClr val="666666"/>
                 </a:solidFill>
-                <a:latin typeface="Marianne"/>
+                <a:latin typeface="Arial"/>
               </a:rPr>
               <a:t>Principes WCAG et critères condensés</a:t>
             </a:r>
@@ -12932,7 +12932,7 @@
                 <a:solidFill>
                   <a:srgbClr val="666666"/>
                 </a:solidFill>
-                <a:latin typeface="Marianne"/>
+                <a:latin typeface="Arial"/>
               </a:rPr>
               <a:t>7</a:t>
             </a:r>
@@ -12972,7 +12972,7 @@
                 <a:solidFill>
                   <a:srgbClr val="000091"/>
                 </a:solidFill>
-                <a:latin typeface="Marianne"/>
+                <a:latin typeface="Arial"/>
               </a:rPr>
               <a:t>Toutes les actions doivent rester possibles sans piège : clavier, temps suffisant, navigation claire, gestes alternatifs.</a:t>
             </a:r>
@@ -13055,7 +13055,7 @@
                 <a:solidFill>
                   <a:srgbClr val="000091"/>
                 </a:solidFill>
-                <a:latin typeface="Marianne"/>
+                <a:latin typeface="Arial"/>
               </a:rPr>
               <a:t>Trois flashs</a:t>
             </a:r>
@@ -13094,7 +13094,7 @@
                 <a:solidFill>
                   <a:srgbClr val="161616"/>
                 </a:solidFill>
-                <a:latin typeface="Marianne"/>
+                <a:latin typeface="Arial"/>
               </a:rPr>
               <a:t>Le contenu ne doit pas clignoter plus de trois fois par seconde (sans exception, même s'il respecte les seuils de sécurité).</a:t>
             </a:r>
@@ -13177,7 +13177,7 @@
                 <a:solidFill>
                   <a:srgbClr val="000091"/>
                 </a:solidFill>
-                <a:latin typeface="Marianne"/>
+                <a:latin typeface="Arial"/>
               </a:rPr>
               <a:t>Animation résultant d'interactions</a:t>
             </a:r>
@@ -13216,7 +13216,7 @@
                 <a:solidFill>
                   <a:srgbClr val="161616"/>
                 </a:solidFill>
-                <a:latin typeface="Marianne"/>
+                <a:latin typeface="Arial"/>
               </a:rPr>
               <a:t>Les animations déclenchées par une interaction (par exemple, un clic, un survol, un tapotement) doivent pouvoir être désactivées via les paramètres système (par exemple, "réduire les mouvements") ou désactivées via une option disponible sur le site.</a:t>
             </a:r>
@@ -13299,7 +13299,7 @@
                 <a:solidFill>
                   <a:srgbClr val="000091"/>
                 </a:solidFill>
-                <a:latin typeface="Marianne"/>
+                <a:latin typeface="Arial"/>
               </a:rPr>
               <a:t>Parcours du focus</a:t>
             </a:r>
@@ -13338,7 +13338,7 @@
                 <a:solidFill>
                   <a:srgbClr val="161616"/>
                 </a:solidFill>
-                <a:latin typeface="Marianne"/>
+                <a:latin typeface="Arial"/>
               </a:rPr>
               <a:t>Le focus doit suivre un ordre logique qui préserve les relations et qui correspond à la façon dont la page se lit naturellement, indépendamment de la mise en page ou du sens de lecture.</a:t>
             </a:r>
@@ -13421,7 +13421,7 @@
                 <a:solidFill>
                   <a:srgbClr val="000091"/>
                 </a:solidFill>
-                <a:latin typeface="Marianne"/>
+                <a:latin typeface="Arial"/>
               </a:rPr>
               <a:t>Fonction du lien (selon le contexte)</a:t>
             </a:r>
@@ -13460,7 +13460,7 @@
                 <a:solidFill>
                   <a:srgbClr val="161616"/>
                 </a:solidFill>
-                <a:latin typeface="Marianne"/>
+                <a:latin typeface="Arial"/>
               </a:rPr>
               <a:t>La fonction de chaque lien doit être compréhensible à partir du texte du lien, ou du contexte environnant.</a:t>
             </a:r>
@@ -13492,7 +13492,7 @@
                 <a:solidFill>
                   <a:srgbClr val="666666"/>
                 </a:solidFill>
-                <a:latin typeface="Marianne"/>
+                <a:latin typeface="Arial"/>
               </a:rPr>
               <a:t>9 octobre 2026</a:t>
             </a:r>
@@ -13530,7 +13530,7 @@
                 <a:solidFill>
                   <a:srgbClr val="666666"/>
                 </a:solidFill>
-                <a:latin typeface="Marianne"/>
+                <a:latin typeface="Arial"/>
               </a:rPr>
               <a:t>WCAG en langage clair / Utiliser sans obstacle</a:t>
             </a:r>
@@ -13761,7 +13761,7 @@
                 <a:solidFill>
                   <a:srgbClr val="000091"/>
                 </a:solidFill>
-                <a:latin typeface="Marianne"/>
+                <a:latin typeface="Arial"/>
               </a:rPr>
               <a:t>Utiliser sans obstacle - critères (2/3)</a:t>
             </a:r>
@@ -13794,7 +13794,7 @@
                 <a:solidFill>
                   <a:srgbClr val="666666"/>
                 </a:solidFill>
-                <a:latin typeface="Marianne"/>
+                <a:latin typeface="Arial"/>
               </a:rPr>
               <a:t>Principes WCAG et critères condensés</a:t>
             </a:r>
@@ -13826,7 +13826,7 @@
                 <a:solidFill>
                   <a:srgbClr val="666666"/>
                 </a:solidFill>
-                <a:latin typeface="Marianne"/>
+                <a:latin typeface="Arial"/>
               </a:rPr>
               <a:t>8</a:t>
             </a:r>
@@ -13910,7 +13910,7 @@
                 <a:solidFill>
                   <a:srgbClr val="000091"/>
                 </a:solidFill>
-                <a:latin typeface="Marianne"/>
+                <a:latin typeface="Arial"/>
               </a:rPr>
               <a:t>Contourner des blocs</a:t>
             </a:r>
@@ -13949,7 +13949,7 @@
                 <a:solidFill>
                   <a:srgbClr val="161616"/>
                 </a:solidFill>
-                <a:latin typeface="Marianne"/>
+                <a:latin typeface="Arial"/>
               </a:rPr>
               <a:t>Les blocs de contenu répétés sur plusieurs pages doivent pouvoir être ignorés (par exemple, la navigation, l'en-tête) pour accéder directement à la partie principale de la page.</a:t>
             </a:r>
@@ -14032,7 +14032,7 @@
                 <a:solidFill>
                   <a:srgbClr val="000091"/>
                 </a:solidFill>
-                <a:latin typeface="Marianne"/>
+                <a:latin typeface="Arial"/>
               </a:rPr>
               <a:t>Titre de page</a:t>
             </a:r>
@@ -14071,7 +14071,7 @@
                 <a:solidFill>
                   <a:srgbClr val="161616"/>
                 </a:solidFill>
-                <a:latin typeface="Marianne"/>
+                <a:latin typeface="Arial"/>
               </a:rPr>
               <a:t>Chaque page doit posséder un attribut &lt;title&gt; unique et explicite qui reflète sa thématique ou son objectif.</a:t>
             </a:r>
@@ -14154,7 +14154,7 @@
                 <a:solidFill>
                   <a:srgbClr val="000091"/>
                 </a:solidFill>
-                <a:latin typeface="Marianne"/>
+                <a:latin typeface="Arial"/>
               </a:rPr>
               <a:t>Accès multiples</a:t>
             </a:r>
@@ -14193,7 +14193,7 @@
                 <a:solidFill>
                   <a:srgbClr val="161616"/>
                 </a:solidFill>
-                <a:latin typeface="Marianne"/>
+                <a:latin typeface="Arial"/>
               </a:rPr>
               <a:t>Il est essentiel de proposer au moins deux méthodes différentes pour accéder aux pages ou au contenu (par exemple, via des menus de navigation, des liens sur la page ou une recherche sur le site).</a:t>
             </a:r>
@@ -14276,7 +14276,7 @@
                 <a:solidFill>
                   <a:srgbClr val="000091"/>
                 </a:solidFill>
-                <a:latin typeface="Marianne"/>
+                <a:latin typeface="Arial"/>
               </a:rPr>
               <a:t>En-têtes et étiquettes</a:t>
             </a:r>
@@ -14315,7 +14315,7 @@
                 <a:solidFill>
                   <a:srgbClr val="161616"/>
                 </a:solidFill>
-                <a:latin typeface="Marianne"/>
+                <a:latin typeface="Arial"/>
               </a:rPr>
               <a:t>Les en-têtes doivent décrire le contenu qui suit.
 Les étiquettes et les boutons doivent permettre d'identifier sans ambiguïté l'information à saisir ou l'action déclenchée.</a:t>
@@ -14348,7 +14348,7 @@
                 <a:solidFill>
                   <a:srgbClr val="666666"/>
                 </a:solidFill>
-                <a:latin typeface="Marianne"/>
+                <a:latin typeface="Arial"/>
               </a:rPr>
               <a:t>9 octobre 2026</a:t>
             </a:r>
@@ -14386,7 +14386,7 @@
                 <a:solidFill>
                   <a:srgbClr val="666666"/>
                 </a:solidFill>
-                <a:latin typeface="Marianne"/>
+                <a:latin typeface="Arial"/>
               </a:rPr>
               <a:t>WCAG en langage clair / Utiliser sans obstacle</a:t>
             </a:r>
@@ -14617,7 +14617,7 @@
                 <a:solidFill>
                   <a:srgbClr val="000091"/>
                 </a:solidFill>
-                <a:latin typeface="Marianne"/>
+                <a:latin typeface="Arial"/>
               </a:rPr>
               <a:t>Utiliser sans obstacle - critères (3/3)</a:t>
             </a:r>
@@ -14650,7 +14650,7 @@
                 <a:solidFill>
                   <a:srgbClr val="666666"/>
                 </a:solidFill>
-                <a:latin typeface="Marianne"/>
+                <a:latin typeface="Arial"/>
               </a:rPr>
               <a:t>Principes WCAG et critères condensés</a:t>
             </a:r>
@@ -14682,7 +14682,7 @@
                 <a:solidFill>
                   <a:srgbClr val="666666"/>
                 </a:solidFill>
-                <a:latin typeface="Marianne"/>
+                <a:latin typeface="Arial"/>
               </a:rPr>
               <a:t>9</a:t>
             </a:r>
@@ -14766,7 +14766,7 @@
                 <a:solidFill>
                   <a:srgbClr val="000091"/>
                 </a:solidFill>
-                <a:latin typeface="Marianne"/>
+                <a:latin typeface="Arial"/>
               </a:rPr>
               <a:t>Modalités d'entrées concurrentes</a:t>
             </a:r>
@@ -14805,7 +14805,7 @@
                 <a:solidFill>
                   <a:srgbClr val="161616"/>
                 </a:solidFill>
-                <a:latin typeface="Marianne"/>
+                <a:latin typeface="Arial"/>
               </a:rPr>
               <a:t>Il doit être possible de passer d'une méthode de saisie à une autre (souris, clavier, écran tactile, commande vocale) tout en conservant l'accès à toutes les fonctionnalités.</a:t>
             </a:r>
@@ -14888,7 +14888,7 @@
                 <a:solidFill>
                   <a:srgbClr val="000091"/>
                 </a:solidFill>
-                <a:latin typeface="Marianne"/>
+                <a:latin typeface="Arial"/>
               </a:rPr>
               <a:t>Mouvements de glissement</a:t>
             </a:r>
@@ -14927,7 +14927,7 @@
                 <a:solidFill>
                   <a:srgbClr val="161616"/>
                 </a:solidFill>
-                <a:latin typeface="Marianne"/>
+                <a:latin typeface="Arial"/>
               </a:rPr>
               <a:t>Les actions nécessitant un glissement (comme le réarrangement d'éléments) doivent également être réalisables à l'aide de boutons ou d'une autre méthode qui ne nécessite pas de glissement.</a:t>
             </a:r>
@@ -14959,7 +14959,7 @@
                 <a:solidFill>
                   <a:srgbClr val="666666"/>
                 </a:solidFill>
-                <a:latin typeface="Marianne"/>
+                <a:latin typeface="Arial"/>
               </a:rPr>
               <a:t>9 octobre 2026</a:t>
             </a:r>
@@ -14997,7 +14997,7 @@
                 <a:solidFill>
                   <a:srgbClr val="666666"/>
                 </a:solidFill>
-                <a:latin typeface="Marianne"/>
+                <a:latin typeface="Arial"/>
               </a:rPr>
               <a:t>WCAG en langage clair / Utiliser sans obstacle</a:t>
             </a:r>

</xml_diff>